<commit_message>
Remove all "game" framing — full Digital Twin pivot
- Default --engine 'unity' → 'omniverse' (config.py)
- Docstrings / labels / CLI help: game-ready → DT-ready
- Region-split mode reframed as LOD/modular, not game/LOD
- Color clean strength options no longer mention game LOD
- report.py next-step suggests Omniverse/Twinmotion/BIM import
- pipeline.py + export.py: engine choices keep legacy realtime
  axis conversion but DT engines are listed first
- Regenerated CleanMesh_기술문서.docx + CleanMesh_매뉴얼.pptx
</commit_message>
<xml_diff>
--- a/CleanMesh_매뉴얼.pptx
+++ b/CleanMesh_매뉴얼.pptx
@@ -3293,7 +3293,7 @@
                 </a:solidFill>
                 <a:latin typeface="맑은 고딕"/>
               </a:rPr>
-              <a:t>2026-06-23</a:t>
+              <a:t>2026-06-24</a:t>
             </a:r>
           </a:p>
         </p:txBody>
@@ -8674,7 +8674,7 @@
                 </a:solidFill>
                 <a:latin typeface="맑은 고딕"/>
               </a:rPr>
-              <a:t>USD / GLB로 익스포트 → Omniverse / Twinmotion / Unreal DT로</a:t>
+              <a:t>USD / GLB로 익스포트 → Omniverse / Twinmotion / BIM 협업툴로</a:t>
             </a:r>
           </a:p>
         </p:txBody>
@@ -11682,7 +11682,7 @@
                           </a:solidFill>
                           <a:latin typeface="맑은 고딕"/>
                         </a:rPr>
-                        <a:t>게임/LOD, DT 비권장</a:t>
+                        <a:t>단색 LOD · 모듈화 용 (DT 비권장)</a:t>
                       </a:r>
                     </a:p>
                   </a:txBody>

</xml_diff>